<commit_message>
demo: fold in VALIDATED served weights result (base 45% -> tuned 66.7%, +21.7 pts)
The Lightning run closed the loop: served base-vs-tuned Qwen3-14B on one vLLM endpoint,
same seed prompt + 60-item eval. Updated charts (4_two_axes_validated), deck, and
JUDGES_SUMMARY to lead with the validated served accuracy instead of the loss proxy;
softened over-claims (split infra Nebius-train/Lightning-serve; different base models per axis).

Co-Authored-By: Claude Opus 4.8 <noreply@anthropic.com>
</commit_message>
<xml_diff>
--- a/demo/Haggle_SIA_Nebius.pptx
+++ b/demo/Haggle_SIA_Nebius.pptx
@@ -1864,7 +1864,7 @@
                 <a:ea typeface="Calibri" pitchFamily="34" charset="-122"/>
                 <a:cs typeface="Calibri" pitchFamily="34" charset="-120"/>
               </a:rPr>
-              <a:t>AXIS 2 · WEIGHTS  (LoRA fine-tune)</a:t>
+              <a:t>AXIS 2 · WEIGHTS  (LoRA fine-tune, served)</a:t>
             </a:r>
             <a:endParaRPr lang="en-US" sz="1300" dirty="0"/>
           </a:p>
@@ -1903,7 +1903,7 @@
                 <a:ea typeface="Trebuchet MS" pitchFamily="34" charset="-122"/>
                 <a:cs typeface="Trebuchet MS" pitchFamily="34" charset="-120"/>
               </a:rPr>
-              <a:t>loss 0.69 → 0.375</a:t>
+              <a:t>45% → 66.7%</a:t>
             </a:r>
             <a:endParaRPr lang="en-US" sz="3200" dirty="0"/>
           </a:p>
@@ -1942,7 +1942,7 @@
                 <a:ea typeface="Calibri" pitchFamily="34" charset="-122"/>
                 <a:cs typeface="Calibri" pitchFamily="34" charset="-120"/>
               </a:rPr>
-              <a:t>Llama-3.3-70B tuned on Nebius GPUs — same API key.</a:t>
+              <a:t>Qwen3-14B fine-tuned + served — +21.7 pts (beats base 70B).</a:t>
             </a:r>
             <a:endParaRPr lang="en-US" sz="1250" dirty="0"/>
           </a:p>
@@ -1950,7 +1950,7 @@
       </p:sp>
       <p:pic>
         <p:nvPicPr>
-          <p:cNvPr id="13" name="Image 0" descr="/Users/kishorebhatia/Development/studio/sia-sf-hackerhouse/oss-sia-haggle/demo/3_two_axes_summary.png">    </p:cNvPr>
+          <p:cNvPr id="13" name="Image 0" descr="/Users/kishorebhatia/Development/studio/sia-sf-hackerhouse/oss-sia-haggle/demo/4_two_axes_validated.png">    </p:cNvPr>
           <p:cNvPicPr>
             <a:picLocks noChangeAspect="1"/>
           </p:cNvPicPr>
@@ -2037,7 +2037,7 @@
                 <a:ea typeface="Trebuchet MS" pitchFamily="34" charset="-122"/>
                 <a:cs typeface="Trebuchet MS" pitchFamily="34" charset="-120"/>
               </a:rPr>
-              <a:t>What the LoRA loss means — and the implication</a:t>
+              <a:t>Weights axis — it learned, and it translated to accuracy</a:t>
             </a:r>
             <a:endParaRPr lang="en-US" sz="3000" dirty="0"/>
           </a:p>
@@ -2221,7 +2221,7 @@
                 <a:ea typeface="Calibri" pitchFamily="34" charset="-122"/>
                 <a:cs typeface="Calibri" pitchFamily="34" charset="-120"/>
               </a:rPr>
-              <a:t>IMPLICATION</a:t>
+              <a:t>VALIDATED (served)</a:t>
             </a:r>
             <a:endParaRPr lang="en-US" sz="1200" dirty="0"/>
           </a:p>
@@ -2263,7 +2263,7 @@
                 <a:ea typeface="Calibri" pitchFamily="34" charset="-122"/>
                 <a:cs typeface="Calibri" pitchFamily="34" charset="-120"/>
               </a:rPr>
-              <a:t>The model itself got better at the task — a second, composable axis of self-improvement beyond prompt/code. </a:t>
+              <a:t>Loss dropping is necessary, not sufficient — so we served it and measured. </a:t>
             </a:r>
             <a:pPr indent="0" marL="0">
               <a:lnSpc>
@@ -2280,7 +2280,7 @@
                 <a:ea typeface="Calibri" pitchFamily="34" charset="-122"/>
                 <a:cs typeface="Calibri" pitchFamily="34" charset="-120"/>
               </a:rPr>
-              <a:t>Lower held-out loss ⇒ higher expected served ±10% accuracy</a:t>
+              <a:t>Base 45% → fine-tuned 66.7% (+21.7 pts)</a:t>
             </a:r>
             <a:pPr indent="0" marL="0">
               <a:lnSpc>
@@ -2297,7 +2297,7 @@
                 <a:ea typeface="Calibri" pitchFamily="34" charset="-122"/>
                 <a:cs typeface="Calibri" pitchFamily="34" charset="-120"/>
               </a:rPr>
-              <a:t> (live serving is one Nebius account toggle away).</a:t>
+              <a:t>, same prompt &amp; eval set. The tuned 14B even beats the base 70B. Nebius trains, Lightning serves — loop closed.</a:t>
             </a:r>
             <a:endParaRPr lang="en-US" sz="1400" dirty="0"/>
           </a:p>
@@ -2692,7 +2692,7 @@
             <a:avLst/>
           </a:prstGeom>
           <a:solidFill>
-            <a:srgbClr val="4285F4"/>
+            <a:srgbClr val="0F9D58"/>
           </a:solidFill>
           <a:ln/>
         </p:spPr>
@@ -2730,7 +2730,7 @@
                 <a:ea typeface="Trebuchet MS" pitchFamily="34" charset="-122"/>
                 <a:cs typeface="Trebuchet MS" pitchFamily="34" charset="-120"/>
               </a:rPr>
-              <a:t>Honest status</a:t>
+              <a:t>Both axes validated</a:t>
             </a:r>
             <a:endParaRPr lang="en-US" sz="1800" dirty="0"/>
           </a:p>
@@ -2772,7 +2772,7 @@
                 <a:ea typeface="Calibri" pitchFamily="34" charset="-122"/>
                 <a:cs typeface="Calibri" pitchFamily="34" charset="-120"/>
               </a:rPr>
-              <a:t>Harness curve + LoRA training curve are live; served base-vs-tuned accuracy is one support toggle (LoRA inference) away from the full 2×2.</a:t>
+              <a:t>Harness 44→65% (code/prompt) AND weights 45→66.7% (served LoRA) — both real ±10% accuracy on held-out negotiations. Nebius trains, Lightning serves.</a:t>
             </a:r>
             <a:endParaRPr lang="en-US" sz="1400" dirty="0"/>
           </a:p>

</xml_diff>

<commit_message>
rigor: single-model 2x2 — scrub 70B cross-ref, add Qwen3 no-think + C/D runbook
- deck/summary: weights story is now purely the controlled Qwen3-14B base-vs-(base+LoRA)
  comparison on one endpoint (+21.7 pts); removed the misleading 70B cross-model line and the
  70B loss curve from slide 3 (replaced with a 14B served-accuracy bar). No 70B anywhere.
- reference_target_agent.py + task.md: disable Qwen3 <think> (graceful fallback) so the BASE
  14B harness run (Cell C) produces JSON instead of scoring the 25% no-deal floor.
- profiles/qwen14b-local-target.json + dualclimb_chart.py + README: isolated-venv runbook to
  run SIA's harness on the SAME local 14B (base vs tuned) -> full 2x2 / dual hill-climb.

Co-Authored-By: Claude Opus 4.8 <noreply@anthropic.com>
</commit_message>
<xml_diff>
--- a/demo/Haggle_SIA_Nebius.pptx
+++ b/demo/Haggle_SIA_Nebius.pptx
@@ -1942,7 +1942,7 @@
                 <a:ea typeface="Calibri" pitchFamily="34" charset="-122"/>
                 <a:cs typeface="Calibri" pitchFamily="34" charset="-120"/>
               </a:rPr>
-              <a:t>Qwen3-14B fine-tuned + served — +21.7 pts (beats base 70B).</a:t>
+              <a:t>Same Qwen3-14B, ± LoRA adapter, one endpoint — +21.7 pts.</a:t>
             </a:r>
             <a:endParaRPr lang="en-US" sz="1250" dirty="0"/>
           </a:p>
@@ -2045,7 +2045,7 @@
       </p:sp>
       <p:pic>
         <p:nvPicPr>
-          <p:cNvPr id="3" name="Image 0" descr="/Users/kishorebhatia/Development/studio/sia-sf-hackerhouse/oss-sia-haggle/demo/2_weights_losscurve.png">    </p:cNvPr>
+          <p:cNvPr id="3" name="Image 0" descr="/Users/kishorebhatia/Development/studio/sia-sf-hackerhouse/oss-sia-haggle/demo/5_weights_served.png">    </p:cNvPr>
           <p:cNvPicPr>
             <a:picLocks noChangeAspect="1"/>
           </p:cNvPicPr>
@@ -2059,8 +2059,8 @@
         </p:blipFill>
         <p:spPr>
           <a:xfrm>
-            <a:off x="548640" y="1325880"/>
-            <a:ext cx="5760720" cy="3602736"/>
+            <a:off x="548640" y="1371600"/>
+            <a:ext cx="5760720" cy="4224528"/>
           </a:xfrm>
           <a:prstGeom prst="rect">
             <a:avLst/>
@@ -2107,7 +2107,7 @@
                 <a:ea typeface="Calibri" pitchFamily="34" charset="-122"/>
                 <a:cs typeface="Calibri" pitchFamily="34" charset="-120"/>
               </a:rPr>
-              <a:t>Per-token cross-entropy on the predicted price — how “surprised” the model is by the correct settled price. Lower = more probability on the right answer.</a:t>
+              <a:t>Served the base AND the LoRA-tuned model on ONE vLLM endpoint, scored with the same seed prompt on the same 60 held-out negotiations.</a:t>
             </a:r>
             <a:endParaRPr lang="en-US" sz="1450" dirty="0"/>
           </a:p>
@@ -2131,7 +2131,7 @@
                 <a:ea typeface="Calibri" pitchFamily="34" charset="-122"/>
                 <a:cs typeface="Calibri" pitchFamily="34" charset="-120"/>
               </a:rPr>
-              <a:t>Held-out (validation) loss fell 0.69 → 0.375 (perplexity ~2.0 → 1.45) right alongside train loss, with a small final gap.</a:t>
+              <a:t>Exactly one variable changes: the LoRA adapter (identical Qwen3-14B weights, base vs base+adapter).</a:t>
             </a:r>
             <a:endParaRPr lang="en-US" sz="1450" dirty="0"/>
           </a:p>
@@ -2155,7 +2155,7 @@
                 <a:ea typeface="Calibri" pitchFamily="34" charset="-122"/>
                 <a:cs typeface="Calibri" pitchFamily="34" charset="-120"/>
               </a:rPr>
-              <a:t>→ it GENERALIZED, didn’t memorize: the LoRA taught Llama-70B the task’s price priors &amp; output format in a way that transfers to unseen negotiations.</a:t>
+              <a:t>→ the +21.7 pts is attributable solely to the fine-tune. (Corroborated by training loss dropping 0.69 → 0.375 — but the headline is served accuracy, not loss.)</a:t>
             </a:r>
             <a:endParaRPr lang="en-US" sz="1450" dirty="0"/>
           </a:p>
@@ -2297,7 +2297,7 @@
                 <a:ea typeface="Calibri" pitchFamily="34" charset="-122"/>
                 <a:cs typeface="Calibri" pitchFamily="34" charset="-120"/>
               </a:rPr>
-              <a:t>, same prompt &amp; eval set. The tuned 14B even beats the base 70B. Nebius trains, Lightning serves — loop closed.</a:t>
+              <a:t>, same prompt, same eval set, identical 14B weights ± the LoRA adapter. Nebius trains, Lightning serves — loop closed.</a:t>
             </a:r>
             <a:endParaRPr lang="en-US" sz="1400" dirty="0"/>
           </a:p>

</xml_diff>

<commit_message>
accuracy + option: weights axis is fully on Lightning; add no-Nebius meta path
- fix wrong 'Nebius trains, Lightning serves' framing: the validated served adapter was
  trained AND served on one Lightning L40S; corrected deck slide-3 box, slide-4 bullets, and
  JUDGES_SUMMARY infra/honest-status. Nebius's roles are now stated accurately (free OSS meta
  engine + an earlier gated fine-tune) and don't touch the validated accuracy.
- add fully-local meta option: providers/local-vllm.json + profiles/qwen14b-local-meta.json +
  serve.sh SERVE_TOOLS=1 (vLLM tool-calling) + README variant, so the whole harness can run
  on-box with zero external keys (with a flake caveat for the 14B code-writer).

Co-Authored-By: Claude Opus 4.8 <noreply@anthropic.com>
</commit_message>
<xml_diff>
--- a/demo/Haggle_SIA_Nebius.pptx
+++ b/demo/Haggle_SIA_Nebius.pptx
@@ -2297,7 +2297,7 @@
                 <a:ea typeface="Calibri" pitchFamily="34" charset="-122"/>
                 <a:cs typeface="Calibri" pitchFamily="34" charset="-120"/>
               </a:rPr>
-              <a:t>, same prompt, same eval set, identical 14B weights ± the LoRA adapter. Nebius trains, Lightning serves — loop closed.</a:t>
+              <a:t>, same prompt, same eval set, identical 14B weights ± the LoRA adapter. Trained + served on one Lightning L40S — loop closed.</a:t>
             </a:r>
             <a:endParaRPr lang="en-US" sz="1400" dirty="0"/>
           </a:p>
@@ -2629,7 +2629,7 @@
                 <a:ea typeface="Trebuchet MS" pitchFamily="34" charset="-122"/>
                 <a:cs typeface="Trebuchet MS" pitchFamily="34" charset="-120"/>
               </a:rPr>
-              <a:t>Open models, one Nebius key</a:t>
+              <a:t>Open models, no frontier dependency</a:t>
             </a:r>
             <a:endParaRPr lang="en-US" sz="1800" dirty="0"/>
           </a:p>
@@ -2671,7 +2671,7 @@
                 <a:ea typeface="Calibri" pitchFamily="34" charset="-122"/>
                 <a:cs typeface="Calibri" pitchFamily="34" charset="-120"/>
               </a:rPr>
-              <a:t>Inference AND GPU fine-tuning through a single API key — no proprietary frontier model needed for the target. Reproducible and cheap.</a:t>
+              <a:t>Free Nebius OSS inference drives the SIA engine; one Lightning L40S does the fine-tune + serving. No proprietary model needed — reproducible and cheap.</a:t>
             </a:r>
             <a:endParaRPr lang="en-US" sz="1400" dirty="0"/>
           </a:p>
@@ -2772,7 +2772,7 @@
                 <a:ea typeface="Calibri" pitchFamily="34" charset="-122"/>
                 <a:cs typeface="Calibri" pitchFamily="34" charset="-120"/>
               </a:rPr>
-              <a:t>Harness 44→65% (code/prompt) AND weights 45→66.7% (served LoRA) — both real ±10% accuracy on held-out negotiations. Nebius trains, Lightning serves.</a:t>
+              <a:t>Harness 44→65% (code/prompt) AND weights 45→66.7% (served LoRA) — both real ±10% accuracy on held-out negotiations, all on open models.</a:t>
             </a:r>
             <a:endParaRPr lang="en-US" sz="1400" dirty="0"/>
           </a:p>

</xml_diff>